<commit_message>
Clarify Module 3 authorization layers
Co-authored-by: Copilot App <223556219+Copilot@users.noreply.github.com>
</commit_message>
<xml_diff>
--- a/decks/day5/module-3-identity-security.pptx
+++ b/decks/day5/module-3-identity-security.pptx
@@ -4,6 +4,9 @@
   <p:sldMasterIdLst>
     <p:sldMasterId id="2147483648" r:id="rId1"/>
   </p:sldMasterIdLst>
+  <p:notesMasterIdLst>
+    <p:notesMasterId r:id="rId11"/>
+  </p:notesMasterIdLst>
   <p:sldIdLst>
     <p:sldId id="256" r:id="rId2"/>
     <p:sldId id="257" r:id="rId3"/>
@@ -15,9 +18,6 @@
     <p:sldId id="263" r:id="rId9"/>
     <p:sldId id="264" r:id="rId10"/>
   </p:sldIdLst>
-  <p:notesMasterIdLst>
-    <p:notesMasterId r:id="rId11"/>
-  </p:notesMasterIdLst>
   <p:sldSz cx="12192000" cy="6858000"/>
   <p:notesSz cx="6858000" cy="12192000"/>
   <p:defaultTextStyle>
@@ -112,6 +112,11 @@
       </a:defRPr>
     </a:lvl9pPr>
   </p:defaultTextStyle>
+  <p:extLst>
+    <p:ext uri="{EFAFB233-063F-42B5-8137-9DF3F51BA10A}">
+      <p15:sldGuideLst xmlns:p15="http://schemas.microsoft.com/office/powerpoint/2012/main"/>
+    </p:ext>
+  </p:extLst>
 </p:presentation>
 </file>
 
@@ -137,234 +142,10 @@
           <a:chExt cx="0" cy="0"/>
         </a:xfrm>
       </p:grpSpPr>
-      <p:sp>
-        <p:nvSpPr>
-          <p:cNvPr id="2" name="Header Placeholder 1"/>
-          <p:cNvSpPr>
-            <a:spLocks noGrp="1"/>
-          </p:cNvSpPr>
-          <p:nvPr>
-            <p:ph type="hdr" sz="quarter"/>
-          </p:nvPr>
-        </p:nvSpPr>
-        <p:spPr>
-          <a:xfrm>
-            <a:off x="0" y="0"/>
-            <a:ext cx="2971800" cy="458788"/>
-          </a:xfrm>
-          <a:prstGeom prst="rect">
-            <a:avLst/>
-          </a:prstGeom>
-        </p:spPr>
-        <p:txBody>
-          <a:bodyPr vert="horz" lIns="91440" tIns="45720" rIns="91440" bIns="45720" rtlCol="0"/>
-          <a:lstStyle>
-            <a:lvl1pPr algn="l">
-              <a:defRPr sz="1200"/>
-            </a:lvl1pPr>
-          </a:lstStyle>
-          <a:p>
-            <a:endParaRPr lang="en-US"/>
-          </a:p>
-        </p:txBody>
-      </p:sp>
-      <p:sp>
-        <p:nvSpPr>
-          <p:cNvPr id="3" name="Date Placeholder 2"/>
-          <p:cNvSpPr>
-            <a:spLocks noGrp="1"/>
-          </p:cNvSpPr>
-          <p:nvPr>
-            <p:ph type="dt" idx="1"/>
-          </p:nvPr>
-        </p:nvSpPr>
-        <p:spPr>
-          <a:xfrm>
-            <a:off x="3884613" y="0"/>
-            <a:ext cx="2971800" cy="458788"/>
-          </a:xfrm>
-          <a:prstGeom prst="rect">
-            <a:avLst/>
-          </a:prstGeom>
-        </p:spPr>
-        <p:txBody>
-          <a:bodyPr vert="horz" lIns="91440" tIns="45720" rIns="91440" bIns="45720" rtlCol="0"/>
-          <a:lstStyle>
-            <a:lvl1pPr algn="r">
-              <a:defRPr sz="1200"/>
-            </a:lvl1pPr>
-          </a:lstStyle>
-          <a:p>
-            <a:fld id="{5282F153-3F37-0F45-9E97-73ACFA13230C}" type="datetimeFigureOut">
-              <a:rPr lang="en-US"/>
-              <a:t>7/23/19</a:t>
-            </a:fld>
-            <a:endParaRPr lang="en-US"/>
-          </a:p>
-        </p:txBody>
-      </p:sp>
-      <p:sp>
-        <p:nvSpPr>
-          <p:cNvPr id="4" name="Slide Image Placeholder 3"/>
-          <p:cNvSpPr>
-            <a:spLocks noGrp="1" noRot="1" noChangeAspect="1"/>
-          </p:cNvSpPr>
-          <p:nvPr>
-            <p:ph type="sldImg" idx="2"/>
-          </p:nvPr>
-        </p:nvSpPr>
-        <p:spPr>
-          <a:xfrm>
-            <a:off x="685800" y="1143000"/>
-            <a:ext cx="5486400" cy="3086100"/>
-          </a:xfrm>
-          <a:prstGeom prst="rect">
-            <a:avLst/>
-          </a:prstGeom>
-          <a:noFill/>
-          <a:ln w="12700">
-            <a:solidFill>
-              <a:prstClr val="black"/>
-            </a:solidFill>
-          </a:ln>
-        </p:spPr>
-        <p:txBody>
-          <a:bodyPr vert="horz" lIns="91440" tIns="45720" rIns="91440" bIns="45720" rtlCol="0" anchor="ctr"/>
-          <a:lstStyle/>
-          <a:p>
-            <a:endParaRPr lang="en-US"/>
-          </a:p>
-        </p:txBody>
-      </p:sp>
-      <p:sp>
-        <p:nvSpPr>
-          <p:cNvPr id="5" name="Notes Placeholder 4"/>
-          <p:cNvSpPr>
-            <a:spLocks noGrp="1"/>
-          </p:cNvSpPr>
-          <p:nvPr>
-            <p:ph type="body" sz="quarter" idx="3"/>
-          </p:nvPr>
-        </p:nvSpPr>
-        <p:spPr>
-          <a:xfrm>
-            <a:off x="685800" y="4400550"/>
-            <a:ext cx="5486400" cy="3600450"/>
-          </a:xfrm>
-          <a:prstGeom prst="rect">
-            <a:avLst/>
-          </a:prstGeom>
-        </p:spPr>
-        <p:txBody>
-          <a:bodyPr vert="horz" lIns="91440" tIns="45720" rIns="91440" bIns="45720" rtlCol="0"/>
-          <a:lstStyle/>
-          <a:p>
-            <a:pPr lvl="0"/>
-            <a:r>
-              <a:rPr lang="en-US"/>
-              <a:t>Click to edit Master text styles</a:t>
-            </a:r>
-          </a:p>
-          <a:p>
-            <a:pPr lvl="1"/>
-            <a:r>
-              <a:rPr lang="en-US"/>
-              <a:t>Second level</a:t>
-            </a:r>
-          </a:p>
-          <a:p>
-            <a:pPr lvl="2"/>
-            <a:r>
-              <a:rPr lang="en-US"/>
-              <a:t>Third level</a:t>
-            </a:r>
-          </a:p>
-          <a:p>
-            <a:pPr lvl="3"/>
-            <a:r>
-              <a:rPr lang="en-US"/>
-              <a:t>Fourth level</a:t>
-            </a:r>
-          </a:p>
-          <a:p>
-            <a:pPr lvl="4"/>
-            <a:r>
-              <a:rPr lang="en-US"/>
-              <a:t>Fifth level</a:t>
-            </a:r>
-          </a:p>
-        </p:txBody>
-      </p:sp>
-      <p:sp>
-        <p:nvSpPr>
-          <p:cNvPr id="6" name="Footer Placeholder 5"/>
-          <p:cNvSpPr>
-            <a:spLocks noGrp="1"/>
-          </p:cNvSpPr>
-          <p:nvPr>
-            <p:ph type="ftr" sz="quarter" idx="4"/>
-          </p:nvPr>
-        </p:nvSpPr>
-        <p:spPr>
-          <a:xfrm>
-            <a:off x="0" y="8685213"/>
-            <a:ext cx="2971800" cy="458787"/>
-          </a:xfrm>
-          <a:prstGeom prst="rect">
-            <a:avLst/>
-          </a:prstGeom>
-        </p:spPr>
-        <p:txBody>
-          <a:bodyPr vert="horz" lIns="91440" tIns="45720" rIns="91440" bIns="45720" rtlCol="0" anchor="b"/>
-          <a:lstStyle>
-            <a:lvl1pPr algn="l">
-              <a:defRPr sz="1200"/>
-            </a:lvl1pPr>
-          </a:lstStyle>
-          <a:p>
-            <a:endParaRPr lang="en-US"/>
-          </a:p>
-        </p:txBody>
-      </p:sp>
-      <p:sp>
-        <p:nvSpPr>
-          <p:cNvPr id="7" name="Slide Number Placeholder 6"/>
-          <p:cNvSpPr>
-            <a:spLocks noGrp="1"/>
-          </p:cNvSpPr>
-          <p:nvPr>
-            <p:ph type="sldNum" sz="quarter" idx="5"/>
-          </p:nvPr>
-        </p:nvSpPr>
-        <p:spPr>
-          <a:xfrm>
-            <a:off x="3884613" y="8685213"/>
-            <a:ext cx="2971800" cy="458787"/>
-          </a:xfrm>
-          <a:prstGeom prst="rect">
-            <a:avLst/>
-          </a:prstGeom>
-        </p:spPr>
-        <p:txBody>
-          <a:bodyPr vert="horz" lIns="91440" tIns="45720" rIns="91440" bIns="45720" rtlCol="0" anchor="b"/>
-          <a:lstStyle>
-            <a:lvl1pPr algn="r">
-              <a:defRPr sz="1200"/>
-            </a:lvl1pPr>
-          </a:lstStyle>
-          <a:p>
-            <a:fld id="{CE5E9CC1-C706-0F49-92D6-E571CC5EEA8F}" type="slidenum">
-              <a:rPr lang="en-US"/>
-              <a:t>‹#›</a:t>
-            </a:fld>
-            <a:endParaRPr lang="en-US"/>
-          </a:p>
-        </p:txBody>
-      </p:sp>
     </p:spTree>
     <p:extLst>
       <p:ext uri="{BB962C8B-B14F-4D97-AF65-F5344CB8AC3E}">
-        <p14:creationId xmlns:p14="http://schemas.microsoft.com/office/powerpoint/2010/main" val="1024086991"/>
+        <p14:creationId xmlns:p14="http://schemas.microsoft.com/office/powerpoint/2010/main" val="271618637"/>
       </p:ext>
     </p:extLst>
   </p:cSld>
@@ -513,7 +294,6 @@
               <a:t>• Open with the outcome, not a product tour: we will follow the identity actually presented at each connection, then ask what that principal may do at that resource. No prior lab completion is assumed; all checkpoints use the presenter-prepared reference agent and evidence in the demo runbook.
 • GROUNDING SOURCE: https://learn.microsoft.com/azure/foundry/concepts/authentication-authorization-foundry</a:t>
             </a:r>
-            <a:endParaRPr lang="en-US" dirty="0"/>
           </a:p>
         </p:txBody>
       </p:sp>
@@ -602,7 +382,6 @@
               <a:t>• Spend about three minutes here. Authentication establishes a principal; authorization evaluates that principal's permissions. Repeat the distinction on both Azure surfaces: control-plane RBAC actions govern resource management, while data-plane RBAC dataActions govern runtime use. Success on one surface says nothing about the other.
 • GROUNDING SOURCE: https://learn.microsoft.com/azure/foundry/concepts/authentication-authorization-foundry</a:t>
             </a:r>
-            <a:endParaRPr lang="en-US" dirty="0"/>
           </a:p>
         </p:txBody>
       </p:sp>
@@ -692,7 +471,6 @@
 • GROUNDING SOURCE: https://learn.microsoft.com/azure/foundry/agents/concepts/agent-identity
 • GROUNDING SOURCE: https://learn.microsoft.com/azure/foundry/concepts/authentication-authorization-foundry</a:t>
             </a:r>
-            <a:endParaRPr lang="en-US" dirty="0"/>
           </a:p>
         </p:txBody>
       </p:sp>
@@ -782,7 +560,6 @@
 • GROUNDING SOURCE: https://learn.microsoft.com/azure/foundry/agents/how-to/migrate-agent-applications
 • GROUNDING SOURCE: https://learn.microsoft.com/azure/foundry/agents/concepts/agent-identity</a:t>
             </a:r>
-            <a:endParaRPr lang="en-US" dirty="0"/>
           </a:p>
         </p:txBody>
       </p:sp>
@@ -868,12 +645,11 @@
           <a:p>
             <a:r>
               <a:rPr lang="en-US" dirty="0"/>
-              <a:t>• A role is the allowed action set; scope is where that assignment applies. This table is a workshop decision aid synthesized from the cited role and permission pages, not one universal role recipe. Point out that a single request can pass endpoint RBAC, index RBAC, and still fail document authorization. Use Foundry Agent Consumer—not a developer role—for invocation-only callers.
+              <a:t>• Teach this as three cumulative layers, not as one Azure RBAC formula. A role defines the allowed actions; resource scope defines where the role assignment applies; data-level permission is the workshop umbrella for record-level authorization such as a document ACL or query-time security filter. A request can pass endpoint and index RBAC and still fail document authorization. Use Foundry Agent Consumer at project or agent-endpoint scope for invocation-only callers; Foundry User at project scope for builders; and Log Analytics Reader at the connected Application Insights resource for trace readers. Protected tables also require Privileged Monitoring Data Reader.
 • GROUNDING SOURCE: https://learn.microsoft.com/azure/foundry/concepts/rbac-foundry
 • GROUNDING SOURCE: https://learn.microsoft.com/azure/search/search-document-level-access-overview
 • GROUNDING SOURCE: https://learn.microsoft.com/azure/foundry/observability/how-to/trace-agent-setup</a:t>
             </a:r>
-            <a:endParaRPr lang="en-US" dirty="0"/>
           </a:p>
         </p:txBody>
       </p:sp>
@@ -963,7 +739,6 @@
 • GROUNDING SOURCE: https://learn.microsoft.com/azure/foundry/agents/how-to/mcp-authentication
 • GROUNDING SOURCE: https://learn.microsoft.com/azure/foundry/agents/concepts/agent-identity</a:t>
             </a:r>
-            <a:endParaRPr lang="en-US" dirty="0"/>
           </a:p>
         </p:txBody>
       </p:sp>
@@ -1054,7 +829,6 @@
 • GROUNDING SOURCE: https://learn.microsoft.com/azure/foundry/agents/how-to/foundry-iq-connect
 • GROUNDING SOURCE: https://learn.microsoft.com/azure/search/search-document-level-access-overview</a:t>
             </a:r>
-            <a:endParaRPr lang="en-US" dirty="0"/>
           </a:p>
         </p:txBody>
       </p:sp>
@@ -1146,7 +920,6 @@
 • GROUNDING SOURCE: https://learn.microsoft.com/azure/foundry/agents/how-to/foundry-iq-connect
 • GROUNDING SOURCE: https://learn.microsoft.com/azure/search/search-document-level-access-overview</a:t>
             </a:r>
-            <a:endParaRPr lang="en-US" dirty="0"/>
           </a:p>
         </p:txBody>
       </p:sp>
@@ -1239,7 +1012,6 @@
 • GROUNDING SOURCE: https://learn.microsoft.com/agent-framework/hosting/self-hosting/#secure-session-continuation
 • GROUNDING SOURCE: https://learn.microsoft.com/azure/search/search-document-level-access-overview</a:t>
             </a:r>
-            <a:endParaRPr lang="en-US" dirty="0"/>
           </a:p>
         </p:txBody>
       </p:sp>
@@ -1312,6 +1084,11 @@
 <file path=ppt/slideMasters/slideMaster1.xml><?xml version="1.0" encoding="utf-8"?>
 <p:sldMaster xmlns:a="http://schemas.openxmlformats.org/drawingml/2006/main" xmlns:r="http://schemas.openxmlformats.org/officeDocument/2006/relationships" xmlns:p="http://schemas.openxmlformats.org/presentationml/2006/main">
   <p:cSld>
+    <p:bg>
+      <p:bgRef idx="1001">
+        <a:schemeClr val="bg1"/>
+      </p:bgRef>
+    </p:bg>
     <p:spTree>
       <p:nvGrpSpPr>
         <p:cNvPr id="1" name=""/>
@@ -1594,6 +1371,7 @@
         <a:solidFill>
           <a:srgbClr val="123026"/>
         </a:solidFill>
+        <a:effectLst/>
       </p:bgPr>
     </p:bg>
     <p:spTree>
@@ -1809,11 +1587,11 @@
           <a:bodyPr wrap="square" lIns="0" tIns="0" rIns="0" bIns="0" rtlCol="0" anchor="ctr"/>
           <a:lstStyle/>
           <a:p>
-            <a:pPr algn="ctr" indent="0" marL="0">
-              <a:buNone/>
-            </a:pPr>
-            <a:r>
-              <a:rPr lang="en-US" sz="900" b="1" spc="160" kern="0" dirty="0">
+            <a:pPr marL="0" indent="0" algn="ctr">
+              <a:buNone/>
+            </a:pPr>
+            <a:r>
+              <a:rPr lang="en-US" sz="900" b="1" kern="0" spc="160" dirty="0">
                 <a:solidFill>
                   <a:srgbClr val="123026"/>
                 </a:solidFill>
@@ -1850,7 +1628,7 @@
           </a:bodyPr>
           <a:lstStyle/>
           <a:p>
-            <a:pPr indent="0" marL="0">
+            <a:pPr marL="0" indent="0">
               <a:buNone/>
             </a:pPr>
             <a:r>
@@ -1891,7 +1669,7 @@
           </a:bodyPr>
           <a:lstStyle/>
           <a:p>
-            <a:pPr indent="0" marL="0">
+            <a:pPr marL="0" indent="0">
               <a:buNone/>
             </a:pPr>
             <a:r>
@@ -1974,7 +1752,7 @@
           </a:bodyPr>
           <a:lstStyle/>
           <a:p>
-            <a:pPr indent="0" marL="0">
+            <a:pPr marL="0" indent="0">
               <a:buNone/>
             </a:pPr>
             <a:r>
@@ -2013,7 +1791,7 @@
           <a:bodyPr wrap="square" lIns="0" tIns="0" rIns="0" bIns="0" rtlCol="0" anchor="ctr"/>
           <a:lstStyle/>
           <a:p>
-            <a:pPr algn="ctr" indent="0" marL="0">
+            <a:pPr marL="0" indent="0" algn="ctr">
               <a:buNone/>
             </a:pPr>
             <a:r>
@@ -2052,11 +1830,11 @@
           <a:bodyPr wrap="square" lIns="0" tIns="0" rIns="0" bIns="0" rtlCol="0" anchor="ctr"/>
           <a:lstStyle/>
           <a:p>
-            <a:pPr algn="ctr" indent="0" marL="0">
-              <a:buNone/>
-            </a:pPr>
-            <a:r>
-              <a:rPr lang="en-US" sz="950" b="1" spc="240" kern="0" dirty="0">
+            <a:pPr marL="0" indent="0" algn="ctr">
+              <a:buNone/>
+            </a:pPr>
+            <a:r>
+              <a:rPr lang="en-US" sz="950" b="1" kern="0" spc="240" dirty="0">
                 <a:solidFill>
                   <a:srgbClr val="FFFFFF"/>
                 </a:solidFill>
@@ -2093,7 +1871,7 @@
           </a:bodyPr>
           <a:lstStyle/>
           <a:p>
-            <a:pPr indent="0" marL="0">
+            <a:pPr marL="0" indent="0">
               <a:buNone/>
             </a:pPr>
             <a:r>
@@ -2147,6 +1925,7 @@
         <a:solidFill>
           <a:srgbClr val="F4FBF8"/>
         </a:solidFill>
+        <a:effectLst/>
       </p:bgPr>
     </p:bg>
     <p:spTree>
@@ -2208,11 +1987,11 @@
           </a:bodyPr>
           <a:lstStyle/>
           <a:p>
-            <a:pPr indent="0" marL="0">
-              <a:buNone/>
-            </a:pPr>
-            <a:r>
-              <a:rPr lang="en-US" sz="820" b="1" spc="120" kern="0" dirty="0">
+            <a:pPr marL="0" indent="0">
+              <a:buNone/>
+            </a:pPr>
+            <a:r>
+              <a:rPr lang="en-US" sz="820" b="1" kern="0" spc="120" dirty="0">
                 <a:solidFill>
                   <a:srgbClr val="FFFFFF"/>
                 </a:solidFill>
@@ -2249,7 +2028,7 @@
           </a:bodyPr>
           <a:lstStyle/>
           <a:p>
-            <a:pPr indent="0" marL="0">
+            <a:pPr marL="0" indent="0">
               <a:buNone/>
             </a:pPr>
             <a:r>
@@ -2424,7 +2203,7 @@
           <a:bodyPr wrap="square" lIns="0" tIns="0" rIns="0" bIns="0" rtlCol="0" anchor="ctr"/>
           <a:lstStyle/>
           <a:p>
-            <a:pPr algn="ctr" indent="0" marL="0">
+            <a:pPr marL="0" indent="0" algn="ctr">
               <a:buNone/>
             </a:pPr>
             <a:r>
@@ -2488,7 +2267,7 @@
             <a:prstDash val="solid"/>
           </a:ln>
           <a:effectLst>
-            <a:outerShdw sx="100000" sy="100000" kx="0" ky="0" algn="bl" rotWithShape="0" blurRad="50800" dist="19050" dir="8100000">
+            <a:outerShdw blurRad="50800" dist="19050" dir="8100000" algn="bl" rotWithShape="0">
               <a:srgbClr val="111827">
                 <a:alpha val="11000"/>
               </a:srgbClr>
@@ -2539,11 +2318,11 @@
           <a:bodyPr wrap="square" lIns="0" tIns="0" rIns="0" bIns="0" rtlCol="0" anchor="ctr"/>
           <a:lstStyle/>
           <a:p>
-            <a:pPr algn="ctr" indent="0" marL="0">
-              <a:buNone/>
-            </a:pPr>
-            <a:r>
-              <a:rPr lang="en-US" sz="830" b="1" spc="110" kern="0" dirty="0">
+            <a:pPr marL="0" indent="0" algn="ctr">
+              <a:buNone/>
+            </a:pPr>
+            <a:r>
+              <a:rPr lang="en-US" sz="830" b="1" kern="0" spc="110" dirty="0">
                 <a:solidFill>
                   <a:srgbClr val="FFFFFF"/>
                 </a:solidFill>
@@ -2580,7 +2359,7 @@
           </a:bodyPr>
           <a:lstStyle/>
           <a:p>
-            <a:pPr indent="0" marL="0">
+            <a:pPr marL="0" indent="0">
               <a:buNone/>
             </a:pPr>
             <a:r>
@@ -2699,7 +2478,7 @@
           <a:bodyPr wrap="square" lIns="0" tIns="0" rIns="0" bIns="0" rtlCol="0" anchor="ctr"/>
           <a:lstStyle/>
           <a:p>
-            <a:pPr algn="ctr" indent="0" marL="0">
+            <a:pPr marL="0" indent="0" algn="ctr">
               <a:buNone/>
             </a:pPr>
             <a:r>
@@ -2743,7 +2522,7 @@
             <a:prstDash val="solid"/>
           </a:ln>
           <a:effectLst>
-            <a:outerShdw sx="100000" sy="100000" kx="0" ky="0" algn="bl" rotWithShape="0" blurRad="50800" dist="19050" dir="8100000">
+            <a:outerShdw blurRad="50800" dist="19050" dir="8100000" algn="bl" rotWithShape="0">
               <a:srgbClr val="111827">
                 <a:alpha val="11000"/>
               </a:srgbClr>
@@ -2794,11 +2573,11 @@
           <a:bodyPr wrap="square" lIns="0" tIns="0" rIns="0" bIns="0" rtlCol="0" anchor="ctr"/>
           <a:lstStyle/>
           <a:p>
-            <a:pPr algn="ctr" indent="0" marL="0">
-              <a:buNone/>
-            </a:pPr>
-            <a:r>
-              <a:rPr lang="en-US" sz="830" b="1" spc="110" kern="0" dirty="0">
+            <a:pPr marL="0" indent="0" algn="ctr">
+              <a:buNone/>
+            </a:pPr>
+            <a:r>
+              <a:rPr lang="en-US" sz="830" b="1" kern="0" spc="110" dirty="0">
                 <a:solidFill>
                   <a:srgbClr val="123026"/>
                 </a:solidFill>
@@ -2835,7 +2614,7 @@
           </a:bodyPr>
           <a:lstStyle/>
           <a:p>
-            <a:pPr indent="0" marL="0">
+            <a:pPr marL="0" indent="0">
               <a:buNone/>
             </a:pPr>
             <a:r>
@@ -2911,24 +2690,6 @@
             </a:r>
             <a:endParaRPr lang="en-US" sz="1600" dirty="0"/>
           </a:p>
-          <a:p>
-            <a:pPr marL="342900" indent="-342900">
-              <a:buSzPct val="100000"/>
-              <a:buChar char="•"/>
-            </a:pPr>
-            <a:r>
-              <a:rPr lang="en-US" sz="1600" dirty="0">
-                <a:solidFill>
-                  <a:srgbClr val="183128"/>
-                </a:solidFill>
-                <a:latin typeface="Aptos" pitchFamily="34" charset="0"/>
-                <a:ea typeface="Aptos" pitchFamily="34" charset="-122"/>
-                <a:cs typeface="Aptos" pitchFamily="34" charset="-120"/>
-              </a:rPr>
-              <a:t>A valid identity can still receive a correct denial</a:t>
-            </a:r>
-            <a:endParaRPr lang="en-US" sz="1600" dirty="0"/>
-          </a:p>
         </p:txBody>
       </p:sp>
       <p:sp>
@@ -2972,7 +2733,7 @@
           <a:bodyPr wrap="square" lIns="0" tIns="0" rIns="0" bIns="0" rtlCol="0" anchor="ctr"/>
           <a:lstStyle/>
           <a:p>
-            <a:pPr algn="ctr" indent="0" marL="0">
+            <a:pPr marL="0" indent="0" algn="ctr">
               <a:buNone/>
             </a:pPr>
             <a:r>
@@ -3031,7 +2792,7 @@
           <a:bodyPr wrap="square" lIns="0" tIns="0" rIns="0" bIns="0" rtlCol="0" anchor="ctr"/>
           <a:lstStyle/>
           <a:p>
-            <a:pPr algn="ctr" indent="0" marL="0">
+            <a:pPr marL="0" indent="0" algn="ctr">
               <a:buNone/>
             </a:pPr>
             <a:r>
@@ -3072,7 +2833,7 @@
           </a:bodyPr>
           <a:lstStyle/>
           <a:p>
-            <a:pPr indent="0" marL="0">
+            <a:pPr marL="0" indent="0">
               <a:buNone/>
             </a:pPr>
             <a:r>
@@ -3126,6 +2887,7 @@
         <a:solidFill>
           <a:srgbClr val="F4FBF8"/>
         </a:solidFill>
+        <a:effectLst/>
       </p:bgPr>
     </p:bg>
     <p:spTree>
@@ -3187,11 +2949,11 @@
           </a:bodyPr>
           <a:lstStyle/>
           <a:p>
-            <a:pPr indent="0" marL="0">
-              <a:buNone/>
-            </a:pPr>
-            <a:r>
-              <a:rPr lang="en-US" sz="820" b="1" spc="120" kern="0" dirty="0">
+            <a:pPr marL="0" indent="0">
+              <a:buNone/>
+            </a:pPr>
+            <a:r>
+              <a:rPr lang="en-US" sz="820" b="1" kern="0" spc="120" dirty="0">
                 <a:solidFill>
                   <a:srgbClr val="FFFFFF"/>
                 </a:solidFill>
@@ -3228,7 +2990,7 @@
           </a:bodyPr>
           <a:lstStyle/>
           <a:p>
-            <a:pPr indent="0" marL="0">
+            <a:pPr marL="0" indent="0">
               <a:buNone/>
             </a:pPr>
             <a:r>
@@ -3403,7 +3165,7 @@
           <a:bodyPr wrap="square" lIns="0" tIns="0" rIns="0" bIns="0" rtlCol="0" anchor="ctr"/>
           <a:lstStyle/>
           <a:p>
-            <a:pPr algn="ctr" indent="0" marL="0">
+            <a:pPr marL="0" indent="0" algn="ctr">
               <a:buNone/>
             </a:pPr>
             <a:r>
@@ -3510,7 +3272,7 @@
           <a:bodyPr wrap="square" lIns="0" tIns="0" rIns="0" bIns="0" rtlCol="0" anchor="ctr"/>
           <a:lstStyle/>
           <a:p>
-            <a:pPr algn="ctr" indent="0" marL="0">
+            <a:pPr marL="0" indent="0" algn="ctr">
               <a:buNone/>
             </a:pPr>
             <a:r>
@@ -3554,7 +3316,7 @@
             <a:prstDash val="solid"/>
           </a:ln>
           <a:effectLst>
-            <a:outerShdw sx="100000" sy="100000" kx="0" ky="0" algn="bl" rotWithShape="0" blurRad="50800" dist="19050" dir="8100000">
+            <a:outerShdw blurRad="50800" dist="19050" dir="8100000" algn="bl" rotWithShape="0">
               <a:srgbClr val="111827">
                 <a:alpha val="11000"/>
               </a:srgbClr>
@@ -3585,7 +3347,7 @@
           </a:bodyPr>
           <a:lstStyle/>
           <a:p>
-            <a:pPr algn="ctr" indent="0" marL="0">
+            <a:pPr marL="0" indent="0" algn="ctr">
               <a:buNone/>
             </a:pPr>
             <a:r>
@@ -3626,7 +3388,7 @@
           </a:bodyPr>
           <a:lstStyle/>
           <a:p>
-            <a:pPr algn="ctr" indent="0" marL="0">
+            <a:pPr marL="0" indent="0" algn="ctr">
               <a:buNone/>
             </a:pPr>
             <a:r>
@@ -3690,7 +3452,7 @@
           <a:bodyPr wrap="square" lIns="0" tIns="0" rIns="0" bIns="0" rtlCol="0" anchor="ctr"/>
           <a:lstStyle/>
           <a:p>
-            <a:pPr algn="ctr" indent="0" marL="0">
+            <a:pPr marL="0" indent="0" algn="ctr">
               <a:buNone/>
             </a:pPr>
             <a:r>
@@ -3734,7 +3496,7 @@
             <a:prstDash val="solid"/>
           </a:ln>
           <a:effectLst>
-            <a:outerShdw sx="100000" sy="100000" kx="0" ky="0" algn="bl" rotWithShape="0" blurRad="50800" dist="19050" dir="8100000">
+            <a:outerShdw blurRad="50800" dist="19050" dir="8100000" algn="bl" rotWithShape="0">
               <a:srgbClr val="111827">
                 <a:alpha val="11000"/>
               </a:srgbClr>
@@ -3765,7 +3527,7 @@
           </a:bodyPr>
           <a:lstStyle/>
           <a:p>
-            <a:pPr algn="ctr" indent="0" marL="0">
+            <a:pPr marL="0" indent="0" algn="ctr">
               <a:buNone/>
             </a:pPr>
             <a:r>
@@ -3806,7 +3568,7 @@
           </a:bodyPr>
           <a:lstStyle/>
           <a:p>
-            <a:pPr algn="ctr" indent="0" marL="0">
+            <a:pPr marL="0" indent="0" algn="ctr">
               <a:buNone/>
             </a:pPr>
             <a:r>
@@ -3870,7 +3632,7 @@
           <a:bodyPr wrap="square" lIns="0" tIns="0" rIns="0" bIns="0" rtlCol="0" anchor="ctr"/>
           <a:lstStyle/>
           <a:p>
-            <a:pPr algn="ctr" indent="0" marL="0">
+            <a:pPr marL="0" indent="0" algn="ctr">
               <a:buNone/>
             </a:pPr>
             <a:r>
@@ -3914,7 +3676,7 @@
             <a:prstDash val="solid"/>
           </a:ln>
           <a:effectLst>
-            <a:outerShdw sx="100000" sy="100000" kx="0" ky="0" algn="bl" rotWithShape="0" blurRad="50800" dist="19050" dir="8100000">
+            <a:outerShdw blurRad="50800" dist="19050" dir="8100000" algn="bl" rotWithShape="0">
               <a:srgbClr val="111827">
                 <a:alpha val="11000"/>
               </a:srgbClr>
@@ -3945,7 +3707,7 @@
           </a:bodyPr>
           <a:lstStyle/>
           <a:p>
-            <a:pPr algn="ctr" indent="0" marL="0">
+            <a:pPr marL="0" indent="0" algn="ctr">
               <a:buNone/>
             </a:pPr>
             <a:r>
@@ -3986,7 +3748,7 @@
           </a:bodyPr>
           <a:lstStyle/>
           <a:p>
-            <a:pPr algn="ctr" indent="0" marL="0">
+            <a:pPr marL="0" indent="0" algn="ctr">
               <a:buNone/>
             </a:pPr>
             <a:r>
@@ -4050,7 +3812,7 @@
           <a:bodyPr wrap="square" lIns="0" tIns="0" rIns="0" bIns="0" rtlCol="0" anchor="ctr"/>
           <a:lstStyle/>
           <a:p>
-            <a:pPr algn="ctr" indent="0" marL="0">
+            <a:pPr marL="0" indent="0" algn="ctr">
               <a:buNone/>
             </a:pPr>
             <a:r>
@@ -4094,7 +3856,7 @@
             <a:prstDash val="solid"/>
           </a:ln>
           <a:effectLst>
-            <a:outerShdw sx="100000" sy="100000" kx="0" ky="0" algn="bl" rotWithShape="0" blurRad="50800" dist="19050" dir="8100000">
+            <a:outerShdw blurRad="50800" dist="19050" dir="8100000" algn="bl" rotWithShape="0">
               <a:srgbClr val="111827">
                 <a:alpha val="11000"/>
               </a:srgbClr>
@@ -4125,7 +3887,7 @@
           </a:bodyPr>
           <a:lstStyle/>
           <a:p>
-            <a:pPr algn="ctr" indent="0" marL="0">
+            <a:pPr marL="0" indent="0" algn="ctr">
               <a:buNone/>
             </a:pPr>
             <a:r>
@@ -4166,7 +3928,7 @@
           </a:bodyPr>
           <a:lstStyle/>
           <a:p>
-            <a:pPr algn="ctr" indent="0" marL="0">
+            <a:pPr marL="0" indent="0" algn="ctr">
               <a:buNone/>
             </a:pPr>
             <a:r>
@@ -4229,7 +3991,7 @@
           </a:bodyPr>
           <a:lstStyle/>
           <a:p>
-            <a:pPr algn="ctr" indent="0" marL="0">
+            <a:pPr marL="0" indent="0" algn="ctr">
               <a:buNone/>
             </a:pPr>
             <a:r>
@@ -4270,7 +4032,7 @@
           </a:bodyPr>
           <a:lstStyle/>
           <a:p>
-            <a:pPr indent="0" marL="0">
+            <a:pPr marL="0" indent="0">
               <a:buNone/>
             </a:pPr>
             <a:r>
@@ -4324,6 +4086,7 @@
         <a:solidFill>
           <a:srgbClr val="F4FBF8"/>
         </a:solidFill>
+        <a:effectLst/>
       </p:bgPr>
     </p:bg>
     <p:spTree>
@@ -4385,11 +4148,11 @@
           </a:bodyPr>
           <a:lstStyle/>
           <a:p>
-            <a:pPr indent="0" marL="0">
-              <a:buNone/>
-            </a:pPr>
-            <a:r>
-              <a:rPr lang="en-US" sz="820" b="1" spc="120" kern="0" dirty="0">
+            <a:pPr marL="0" indent="0">
+              <a:buNone/>
+            </a:pPr>
+            <a:r>
+              <a:rPr lang="en-US" sz="820" b="1" kern="0" spc="120" dirty="0">
                 <a:solidFill>
                   <a:srgbClr val="FFFFFF"/>
                 </a:solidFill>
@@ -4426,7 +4189,7 @@
           </a:bodyPr>
           <a:lstStyle/>
           <a:p>
-            <a:pPr indent="0" marL="0">
+            <a:pPr marL="0" indent="0">
               <a:buNone/>
             </a:pPr>
             <a:r>
@@ -4601,7 +4364,7 @@
           <a:bodyPr wrap="square" lIns="0" tIns="0" rIns="0" bIns="0" rtlCol="0" anchor="ctr"/>
           <a:lstStyle/>
           <a:p>
-            <a:pPr algn="ctr" indent="0" marL="0">
+            <a:pPr marL="0" indent="0" algn="ctr">
               <a:buNone/>
             </a:pPr>
             <a:r>
@@ -4665,7 +4428,7 @@
             <a:prstDash val="solid"/>
           </a:ln>
           <a:effectLst>
-            <a:outerShdw sx="100000" sy="100000" kx="0" ky="0" algn="bl" rotWithShape="0" blurRad="50800" dist="19050" dir="8100000">
+            <a:outerShdw blurRad="50800" dist="19050" dir="8100000" algn="bl" rotWithShape="0">
               <a:srgbClr val="111827">
                 <a:alpha val="11000"/>
               </a:srgbClr>
@@ -4716,11 +4479,11 @@
           <a:bodyPr wrap="square" lIns="0" tIns="0" rIns="0" bIns="0" rtlCol="0" anchor="ctr"/>
           <a:lstStyle/>
           <a:p>
-            <a:pPr algn="ctr" indent="0" marL="0">
-              <a:buNone/>
-            </a:pPr>
-            <a:r>
-              <a:rPr lang="en-US" sz="830" b="1" spc="110" kern="0" dirty="0">
+            <a:pPr marL="0" indent="0" algn="ctr">
+              <a:buNone/>
+            </a:pPr>
+            <a:r>
+              <a:rPr lang="en-US" sz="830" b="1" kern="0" spc="110" dirty="0">
                 <a:solidFill>
                   <a:srgbClr val="FFFFFF"/>
                 </a:solidFill>
@@ -4757,7 +4520,7 @@
           </a:bodyPr>
           <a:lstStyle/>
           <a:p>
-            <a:pPr indent="0" marL="0">
+            <a:pPr marL="0" indent="0">
               <a:buNone/>
             </a:pPr>
             <a:r>
@@ -4897,7 +4660,7 @@
             <a:prstDash val="solid"/>
           </a:ln>
           <a:effectLst>
-            <a:outerShdw sx="100000" sy="100000" kx="0" ky="0" algn="bl" rotWithShape="0" blurRad="50800" dist="19050" dir="8100000">
+            <a:outerShdw blurRad="50800" dist="19050" dir="8100000" algn="bl" rotWithShape="0">
               <a:srgbClr val="111827">
                 <a:alpha val="11000"/>
               </a:srgbClr>
@@ -4948,11 +4711,11 @@
           <a:bodyPr wrap="square" lIns="0" tIns="0" rIns="0" bIns="0" rtlCol="0" anchor="ctr"/>
           <a:lstStyle/>
           <a:p>
-            <a:pPr algn="ctr" indent="0" marL="0">
-              <a:buNone/>
-            </a:pPr>
-            <a:r>
-              <a:rPr lang="en-US" sz="830" b="1" spc="110" kern="0" dirty="0">
+            <a:pPr marL="0" indent="0" algn="ctr">
+              <a:buNone/>
+            </a:pPr>
+            <a:r>
+              <a:rPr lang="en-US" sz="830" b="1" kern="0" spc="110" dirty="0">
                 <a:solidFill>
                   <a:srgbClr val="123026"/>
                 </a:solidFill>
@@ -4989,7 +4752,7 @@
           </a:bodyPr>
           <a:lstStyle/>
           <a:p>
-            <a:pPr indent="0" marL="0">
+            <a:pPr marL="0" indent="0">
               <a:buNone/>
             </a:pPr>
             <a:r>
@@ -5126,7 +4889,7 @@
           <a:bodyPr wrap="square" lIns="0" tIns="0" rIns="0" bIns="0" rtlCol="0" anchor="ctr"/>
           <a:lstStyle/>
           <a:p>
-            <a:pPr algn="ctr" indent="0" marL="0">
+            <a:pPr marL="0" indent="0" algn="ctr">
               <a:buNone/>
             </a:pPr>
             <a:r>
@@ -5167,7 +4930,7 @@
           </a:bodyPr>
           <a:lstStyle/>
           <a:p>
-            <a:pPr indent="0" marL="0">
+            <a:pPr marL="0" indent="0">
               <a:buNone/>
             </a:pPr>
             <a:r>
@@ -5221,6 +4984,7 @@
         <a:solidFill>
           <a:srgbClr val="F4FBF8"/>
         </a:solidFill>
+        <a:effectLst/>
       </p:bgPr>
     </p:bg>
     <p:spTree>
@@ -5282,11 +5046,11 @@
           </a:bodyPr>
           <a:lstStyle/>
           <a:p>
-            <a:pPr indent="0" marL="0">
-              <a:buNone/>
-            </a:pPr>
-            <a:r>
-              <a:rPr lang="en-US" sz="820" b="1" spc="120" kern="0" dirty="0">
+            <a:pPr marL="0" indent="0">
+              <a:buNone/>
+            </a:pPr>
+            <a:r>
+              <a:rPr lang="en-US" sz="820" b="1" kern="0" spc="120" dirty="0">
                 <a:solidFill>
                   <a:srgbClr val="FFFFFF"/>
                 </a:solidFill>
@@ -5323,7 +5087,7 @@
           </a:bodyPr>
           <a:lstStyle/>
           <a:p>
-            <a:pPr indent="0" marL="0">
+            <a:pPr marL="0" indent="0">
               <a:buNone/>
             </a:pPr>
             <a:r>
@@ -5335,7 +5099,7 @@
                 <a:ea typeface="Aptos Display" pitchFamily="34" charset="-122"/>
                 <a:cs typeface="Aptos Display" pitchFamily="34" charset="-120"/>
               </a:rPr>
-              <a:t>Least privilege is role × scope × data rule</a:t>
+              <a:t>Least privilege has three authorization layers</a:t>
             </a:r>
             <a:endParaRPr lang="en-US" sz="3100" dirty="0"/>
           </a:p>
@@ -5498,7 +5262,7 @@
           <a:bodyPr wrap="square" lIns="0" tIns="0" rIns="0" bIns="0" rtlCol="0" anchor="ctr"/>
           <a:lstStyle/>
           <a:p>
-            <a:pPr algn="ctr" indent="0" marL="0">
+            <a:pPr marL="0" indent="0" algn="ctr">
               <a:buNone/>
             </a:pPr>
             <a:r>
@@ -5579,11 +5343,11 @@
           <a:bodyPr wrap="square" lIns="0" tIns="0" rIns="0" bIns="0" rtlCol="0" anchor="ctr"/>
           <a:lstStyle/>
           <a:p>
-            <a:pPr algn="ctr" indent="0" marL="0">
-              <a:buNone/>
-            </a:pPr>
-            <a:r>
-              <a:rPr lang="en-US" sz="1500" b="1" spc="180" kern="0" dirty="0">
+            <a:pPr marL="0" indent="0" algn="ctr">
+              <a:buNone/>
+            </a:pPr>
+            <a:r>
+              <a:rPr lang="en-US" sz="1500" b="1" kern="0" spc="180" dirty="0">
                 <a:solidFill>
                   <a:srgbClr val="123026"/>
                 </a:solidFill>
@@ -5618,7 +5382,7 @@
           <a:bodyPr wrap="square" lIns="0" tIns="0" rIns="0" bIns="0" rtlCol="0" anchor="ctr"/>
           <a:lstStyle/>
           <a:p>
-            <a:pPr algn="ctr" indent="0" marL="0">
+            <a:pPr marL="0" indent="0" algn="ctr">
               <a:buNone/>
             </a:pPr>
             <a:r>
@@ -5679,11 +5443,11 @@
           <a:bodyPr wrap="square" lIns="0" tIns="0" rIns="0" bIns="0" rtlCol="0" anchor="ctr"/>
           <a:lstStyle/>
           <a:p>
-            <a:pPr algn="ctr" indent="0" marL="0">
-              <a:buNone/>
-            </a:pPr>
-            <a:r>
-              <a:rPr lang="en-US" sz="1500" b="1" spc="180" kern="0" dirty="0">
+            <a:pPr marL="0" indent="0" algn="ctr">
+              <a:buNone/>
+            </a:pPr>
+            <a:r>
+              <a:rPr lang="en-US" sz="1500" b="1" kern="0" spc="180" dirty="0">
                 <a:solidFill>
                   <a:srgbClr val="123026"/>
                 </a:solidFill>
@@ -5691,7 +5455,7 @@
                 <a:ea typeface="Aptos" pitchFamily="34" charset="-122"/>
                 <a:cs typeface="Aptos" pitchFamily="34" charset="-120"/>
               </a:rPr>
-              <a:t>SCOPE</a:t>
+              <a:t>RESOURCE SCOPE</a:t>
             </a:r>
             <a:endParaRPr lang="en-US" sz="1500" dirty="0"/>
           </a:p>
@@ -5718,7 +5482,7 @@
           <a:bodyPr wrap="square" lIns="0" tIns="0" rIns="0" bIns="0" rtlCol="0" anchor="ctr"/>
           <a:lstStyle/>
           <a:p>
-            <a:pPr algn="ctr" indent="0" marL="0">
+            <a:pPr marL="0" indent="0" algn="ctr">
               <a:buNone/>
             </a:pPr>
             <a:r>
@@ -5779,11 +5543,11 @@
           <a:bodyPr wrap="square" lIns="0" tIns="0" rIns="0" bIns="0" rtlCol="0" anchor="ctr"/>
           <a:lstStyle/>
           <a:p>
-            <a:pPr algn="ctr" indent="0" marL="0">
-              <a:buNone/>
-            </a:pPr>
-            <a:r>
-              <a:rPr lang="en-US" sz="1500" b="1" spc="180" kern="0" dirty="0">
+            <a:pPr marL="0" indent="0" algn="ctr">
+              <a:buNone/>
+            </a:pPr>
+            <a:r>
+              <a:rPr lang="en-US" sz="1500" b="1" kern="0" spc="180" dirty="0">
                 <a:solidFill>
                   <a:srgbClr val="123026"/>
                 </a:solidFill>
@@ -5791,7 +5555,7 @@
                 <a:ea typeface="Aptos" pitchFamily="34" charset="-122"/>
                 <a:cs typeface="Aptos" pitchFamily="34" charset="-120"/>
               </a:rPr>
-              <a:t>DATA RULE</a:t>
+              <a:t>DATA-LEVEL PERMISSION</a:t>
             </a:r>
             <a:endParaRPr lang="en-US" sz="1500" dirty="0"/>
           </a:p>
@@ -5842,11 +5606,11 @@
           </a:bodyPr>
           <a:lstStyle/>
           <a:p>
-            <a:pPr indent="0" marL="0">
-              <a:buNone/>
-            </a:pPr>
-            <a:r>
-              <a:rPr lang="en-US" sz="940" b="1" spc="110" kern="0" dirty="0">
+            <a:pPr marL="0" indent="0">
+              <a:buNone/>
+            </a:pPr>
+            <a:r>
+              <a:rPr lang="en-US" sz="940" b="1" kern="0" spc="110" dirty="0">
                 <a:solidFill>
                   <a:srgbClr val="FFFFFF"/>
                 </a:solidFill>
@@ -5854,7 +5618,7 @@
                 <a:ea typeface="Aptos" pitchFamily="34" charset="-122"/>
                 <a:cs typeface="Aptos" pitchFamily="34" charset="-120"/>
               </a:rPr>
-              <a:t>NEED</a:t>
+              <a:t>LAYER</a:t>
             </a:r>
             <a:endParaRPr lang="en-US" sz="940" dirty="0"/>
           </a:p>
@@ -5905,11 +5669,11 @@
           </a:bodyPr>
           <a:lstStyle/>
           <a:p>
-            <a:pPr indent="0" marL="0">
-              <a:buNone/>
-            </a:pPr>
-            <a:r>
-              <a:rPr lang="en-US" sz="940" b="1" spc="110" kern="0" dirty="0">
+            <a:pPr marL="0" indent="0">
+              <a:buNone/>
+            </a:pPr>
+            <a:r>
+              <a:rPr lang="en-US" sz="940" b="1" kern="0" spc="110" dirty="0">
                 <a:solidFill>
                   <a:srgbClr val="123026"/>
                 </a:solidFill>
@@ -5917,7 +5681,7 @@
                 <a:ea typeface="Aptos" pitchFamily="34" charset="-122"/>
                 <a:cs typeface="Aptos" pitchFamily="34" charset="-120"/>
               </a:rPr>
-              <a:t>PRINCIPAL</a:t>
+              <a:t>QUESTION</a:t>
             </a:r>
             <a:endParaRPr lang="en-US" sz="940" dirty="0"/>
           </a:p>
@@ -5968,11 +5732,11 @@
           </a:bodyPr>
           <a:lstStyle/>
           <a:p>
-            <a:pPr indent="0" marL="0">
-              <a:buNone/>
-            </a:pPr>
-            <a:r>
-              <a:rPr lang="en-US" sz="940" b="1" spc="110" kern="0" dirty="0">
+            <a:pPr marL="0" indent="0">
+              <a:buNone/>
+            </a:pPr>
+            <a:r>
+              <a:rPr lang="en-US" sz="940" b="1" kern="0" spc="110" dirty="0">
                 <a:solidFill>
                   <a:srgbClr val="123026"/>
                 </a:solidFill>
@@ -5980,7 +5744,7 @@
                 <a:ea typeface="Aptos" pitchFamily="34" charset="-122"/>
                 <a:cs typeface="Aptos" pitchFamily="34" charset="-120"/>
               </a:rPr>
-              <a:t>BOUNDARY TO CHECK</a:t>
+              <a:t>EXAMPLE</a:t>
             </a:r>
             <a:endParaRPr lang="en-US" sz="940" dirty="0"/>
           </a:p>
@@ -6036,7 +5800,7 @@
           </a:bodyPr>
           <a:lstStyle/>
           <a:p>
-            <a:pPr indent="0" marL="0">
+            <a:pPr marL="0" indent="0">
               <a:buNone/>
             </a:pPr>
             <a:r>
@@ -6048,7 +5812,7 @@
                 <a:ea typeface="Aptos" pitchFamily="34" charset="-122"/>
                 <a:cs typeface="Aptos" pitchFamily="34" charset="-120"/>
               </a:rPr>
-              <a:t>Invoke the reference agent</a:t>
+              <a:t>Role</a:t>
             </a:r>
             <a:endParaRPr lang="en-US" sz="1460" dirty="0"/>
           </a:p>
@@ -6100,7 +5864,7 @@
           </a:bodyPr>
           <a:lstStyle/>
           <a:p>
-            <a:pPr indent="0" marL="0">
+            <a:pPr marL="0" indent="0">
               <a:buNone/>
             </a:pPr>
             <a:r>
@@ -6112,7 +5876,7 @@
                 <a:ea typeface="Aptos" pitchFamily="34" charset="-122"/>
                 <a:cs typeface="Aptos" pitchFamily="34" charset="-120"/>
               </a:rPr>
-              <a:t>End user or calling app</a:t>
+              <a:t>What actions may the principal perform?</a:t>
             </a:r>
             <a:endParaRPr lang="en-US" sz="1380" dirty="0"/>
           </a:p>
@@ -6164,7 +5928,7 @@
           </a:bodyPr>
           <a:lstStyle/>
           <a:p>
-            <a:pPr indent="0" marL="0">
+            <a:pPr marL="0" indent="0">
               <a:buNone/>
             </a:pPr>
             <a:r>
@@ -6176,7 +5940,7 @@
                 <a:ea typeface="Aptos" pitchFamily="34" charset="-122"/>
                 <a:cs typeface="Aptos" pitchFamily="34" charset="-120"/>
               </a:rPr>
-              <a:t>Foundry Agent Consumer at project or agent endpoint</a:t>
+              <a:t>Foundry Agent Consumer permits invocation</a:t>
             </a:r>
             <a:endParaRPr lang="en-US" sz="1380" dirty="0"/>
           </a:p>
@@ -6232,7 +5996,7 @@
           </a:bodyPr>
           <a:lstStyle/>
           <a:p>
-            <a:pPr indent="0" marL="0">
+            <a:pPr marL="0" indent="0">
               <a:buNone/>
             </a:pPr>
             <a:r>
@@ -6244,7 +6008,7 @@
                 <a:ea typeface="Aptos" pitchFamily="34" charset="-122"/>
                 <a:cs typeface="Aptos" pitchFamily="34" charset="-120"/>
               </a:rPr>
-              <a:t>Build and test agents</a:t>
+              <a:t>Resource scope</a:t>
             </a:r>
             <a:endParaRPr lang="en-US" sz="1460" dirty="0"/>
           </a:p>
@@ -6296,7 +6060,7 @@
           </a:bodyPr>
           <a:lstStyle/>
           <a:p>
-            <a:pPr indent="0" marL="0">
+            <a:pPr marL="0" indent="0">
               <a:buNone/>
             </a:pPr>
             <a:r>
@@ -6308,7 +6072,7 @@
                 <a:ea typeface="Aptos" pitchFamily="34" charset="-122"/>
                 <a:cs typeface="Aptos" pitchFamily="34" charset="-120"/>
               </a:rPr>
-              <a:t>Developer</a:t>
+              <a:t>Where does the role assignment apply?</a:t>
             </a:r>
             <a:endParaRPr lang="en-US" sz="1380" dirty="0"/>
           </a:p>
@@ -6360,7 +6124,7 @@
           </a:bodyPr>
           <a:lstStyle/>
           <a:p>
-            <a:pPr indent="0" marL="0">
+            <a:pPr marL="0" indent="0">
               <a:buNone/>
             </a:pPr>
             <a:r>
@@ -6372,7 +6136,7 @@
                 <a:ea typeface="Aptos" pitchFamily="34" charset="-122"/>
                 <a:cs typeface="Aptos" pitchFamily="34" charset="-120"/>
               </a:rPr>
-              <a:t>Foundry User at project scope</a:t>
+              <a:t>One project or agent endpoint</a:t>
             </a:r>
             <a:endParaRPr lang="en-US" sz="1380" dirty="0"/>
           </a:p>
@@ -6428,7 +6192,7 @@
           </a:bodyPr>
           <a:lstStyle/>
           <a:p>
-            <a:pPr indent="0" marL="0">
+            <a:pPr marL="0" indent="0">
               <a:buNone/>
             </a:pPr>
             <a:r>
@@ -6440,7 +6204,7 @@
                 <a:ea typeface="Aptos" pitchFamily="34" charset="-122"/>
                 <a:cs typeface="Aptos" pitchFamily="34" charset="-120"/>
               </a:rPr>
-              <a:t>Retrieve restricted content</a:t>
+              <a:t>Data-level permission</a:t>
             </a:r>
             <a:endParaRPr lang="en-US" sz="1460" dirty="0"/>
           </a:p>
@@ -6492,7 +6256,7 @@
           </a:bodyPr>
           <a:lstStyle/>
           <a:p>
-            <a:pPr indent="0" marL="0">
+            <a:pPr marL="0" indent="0">
               <a:buNone/>
             </a:pPr>
             <a:r>
@@ -6504,7 +6268,7 @@
                 <a:ea typeface="Aptos" pitchFamily="34" charset="-122"/>
                 <a:cs typeface="Aptos" pitchFamily="34" charset="-120"/>
               </a:rPr>
-              <a:t>Agent/application plus user context</a:t>
+              <a:t>Which records may this user receive?</a:t>
             </a:r>
             <a:endParaRPr lang="en-US" sz="1380" dirty="0"/>
           </a:p>
@@ -6556,7 +6320,7 @@
           </a:bodyPr>
           <a:lstStyle/>
           <a:p>
-            <a:pPr indent="0" marL="0">
+            <a:pPr marL="0" indent="0">
               <a:buNone/>
             </a:pPr>
             <a:r>
@@ -6568,7 +6332,7 @@
                 <a:ea typeface="Aptos" pitchFamily="34" charset="-122"/>
                 <a:cs typeface="Aptos" pitchFamily="34" charset="-120"/>
               </a:rPr>
-              <a:t>Index access and query-time document permission</a:t>
+              <a:t>Document ACL or query-time security filter</a:t>
             </a:r>
             <a:endParaRPr lang="en-US" sz="1380" dirty="0"/>
           </a:p>
@@ -6624,7 +6388,7 @@
           </a:bodyPr>
           <a:lstStyle/>
           <a:p>
-            <a:pPr indent="0" marL="0">
+            <a:pPr marL="0" indent="0">
               <a:buNone/>
             </a:pPr>
             <a:r>
@@ -6636,7 +6400,7 @@
                 <a:ea typeface="Aptos" pitchFamily="34" charset="-122"/>
                 <a:cs typeface="Aptos" pitchFamily="34" charset="-120"/>
               </a:rPr>
-              <a:t>Read traces</a:t>
+              <a:t>ALL THREE</a:t>
             </a:r>
             <a:endParaRPr lang="en-US" sz="1460" dirty="0"/>
           </a:p>
@@ -6688,7 +6452,7 @@
           </a:bodyPr>
           <a:lstStyle/>
           <a:p>
-            <a:pPr indent="0" marL="0">
+            <a:pPr marL="0" indent="0">
               <a:buNone/>
             </a:pPr>
             <a:r>
@@ -6700,7 +6464,7 @@
                 <a:ea typeface="Aptos" pitchFamily="34" charset="-122"/>
                 <a:cs typeface="Aptos" pitchFamily="34" charset="-120"/>
               </a:rPr>
-              <a:t>Operator</a:t>
+              <a:t>Must pass together</a:t>
             </a:r>
             <a:endParaRPr lang="en-US" sz="1380" dirty="0"/>
           </a:p>
@@ -6752,7 +6516,7 @@
           </a:bodyPr>
           <a:lstStyle/>
           <a:p>
-            <a:pPr indent="0" marL="0">
+            <a:pPr marL="0" indent="0">
               <a:buNone/>
             </a:pPr>
             <a:r>
@@ -6764,7 +6528,7 @@
                 <a:ea typeface="Aptos" pitchFamily="34" charset="-122"/>
                 <a:cs typeface="Aptos" pitchFamily="34" charset="-120"/>
               </a:rPr>
-              <a:t>Log Analytics Reader at connected Application Insights; protected tables also need Privileged Monitoring Data Reader</a:t>
+              <a:t>Action allowed + resource in scope + record permitted</a:t>
             </a:r>
             <a:endParaRPr lang="en-US" sz="1380" dirty="0"/>
           </a:p>
@@ -6793,7 +6557,7 @@
           </a:bodyPr>
           <a:lstStyle/>
           <a:p>
-            <a:pPr indent="0" marL="0">
+            <a:pPr marL="0" indent="0">
               <a:buNone/>
             </a:pPr>
             <a:r>
@@ -6847,6 +6611,7 @@
         <a:solidFill>
           <a:srgbClr val="F4FBF8"/>
         </a:solidFill>
+        <a:effectLst/>
       </p:bgPr>
     </p:bg>
     <p:spTree>
@@ -6908,11 +6673,11 @@
           </a:bodyPr>
           <a:lstStyle/>
           <a:p>
-            <a:pPr indent="0" marL="0">
-              <a:buNone/>
-            </a:pPr>
-            <a:r>
-              <a:rPr lang="en-US" sz="820" b="1" spc="120" kern="0" dirty="0">
+            <a:pPr marL="0" indent="0">
+              <a:buNone/>
+            </a:pPr>
+            <a:r>
+              <a:rPr lang="en-US" sz="820" b="1" kern="0" spc="120" dirty="0">
                 <a:solidFill>
                   <a:srgbClr val="FFFFFF"/>
                 </a:solidFill>
@@ -6949,7 +6714,7 @@
           </a:bodyPr>
           <a:lstStyle/>
           <a:p>
-            <a:pPr indent="0" marL="0">
+            <a:pPr marL="0" indent="0">
               <a:buNone/>
             </a:pPr>
             <a:r>
@@ -7124,7 +6889,7 @@
           <a:bodyPr wrap="square" lIns="0" tIns="0" rIns="0" bIns="0" rtlCol="0" anchor="ctr"/>
           <a:lstStyle/>
           <a:p>
-            <a:pPr algn="ctr" indent="0" marL="0">
+            <a:pPr marL="0" indent="0" algn="ctr">
               <a:buNone/>
             </a:pPr>
             <a:r>
@@ -7230,7 +6995,7 @@
           <a:bodyPr wrap="square" lIns="0" tIns="0" rIns="0" bIns="0" rtlCol="0" anchor="ctr"/>
           <a:lstStyle/>
           <a:p>
-            <a:pPr algn="ctr" indent="0" marL="0">
+            <a:pPr marL="0" indent="0" algn="ctr">
               <a:buNone/>
             </a:pPr>
             <a:r>
@@ -7271,7 +7036,7 @@
           </a:bodyPr>
           <a:lstStyle/>
           <a:p>
-            <a:pPr algn="ctr" indent="0" marL="0">
+            <a:pPr marL="0" indent="0" algn="ctr">
               <a:buNone/>
             </a:pPr>
             <a:r>
@@ -7312,7 +7077,7 @@
           </a:bodyPr>
           <a:lstStyle/>
           <a:p>
-            <a:pPr algn="ctr" indent="0" marL="0">
+            <a:pPr marL="0" indent="0" algn="ctr">
               <a:buNone/>
             </a:pPr>
             <a:r>
@@ -7398,7 +7163,7 @@
           <a:bodyPr wrap="square" lIns="0" tIns="0" rIns="0" bIns="0" rtlCol="0" anchor="ctr"/>
           <a:lstStyle/>
           <a:p>
-            <a:pPr algn="ctr" indent="0" marL="0">
+            <a:pPr marL="0" indent="0" algn="ctr">
               <a:buNone/>
             </a:pPr>
             <a:r>
@@ -7439,7 +7204,7 @@
           </a:bodyPr>
           <a:lstStyle/>
           <a:p>
-            <a:pPr algn="ctr" indent="0" marL="0">
+            <a:pPr marL="0" indent="0" algn="ctr">
               <a:buNone/>
             </a:pPr>
             <a:r>
@@ -7480,7 +7245,7 @@
           </a:bodyPr>
           <a:lstStyle/>
           <a:p>
-            <a:pPr algn="ctr" indent="0" marL="0">
+            <a:pPr marL="0" indent="0" algn="ctr">
               <a:buNone/>
             </a:pPr>
             <a:r>
@@ -7566,7 +7331,7 @@
           <a:bodyPr wrap="square" lIns="0" tIns="0" rIns="0" bIns="0" rtlCol="0" anchor="ctr"/>
           <a:lstStyle/>
           <a:p>
-            <a:pPr algn="ctr" indent="0" marL="0">
+            <a:pPr marL="0" indent="0" algn="ctr">
               <a:buNone/>
             </a:pPr>
             <a:r>
@@ -7607,7 +7372,7 @@
           </a:bodyPr>
           <a:lstStyle/>
           <a:p>
-            <a:pPr algn="ctr" indent="0" marL="0">
+            <a:pPr marL="0" indent="0" algn="ctr">
               <a:buNone/>
             </a:pPr>
             <a:r>
@@ -7648,7 +7413,7 @@
           </a:bodyPr>
           <a:lstStyle/>
           <a:p>
-            <a:pPr algn="ctr" indent="0" marL="0">
+            <a:pPr marL="0" indent="0" algn="ctr">
               <a:buNone/>
             </a:pPr>
             <a:r>
@@ -7710,7 +7475,7 @@
           <a:bodyPr wrap="square" lIns="0" tIns="0" rIns="0" bIns="0" rtlCol="0" anchor="ctr"/>
           <a:lstStyle/>
           <a:p>
-            <a:pPr algn="ctr" indent="0" marL="0">
+            <a:pPr marL="0" indent="0" algn="ctr">
               <a:buNone/>
             </a:pPr>
             <a:r>
@@ -7773,11 +7538,11 @@
           </a:bodyPr>
           <a:lstStyle/>
           <a:p>
-            <a:pPr algn="ctr" indent="0" marL="0">
-              <a:buNone/>
-            </a:pPr>
-            <a:r>
-              <a:rPr lang="en-US" sz="880" b="1" spc="80" kern="0" dirty="0">
+            <a:pPr marL="0" indent="0" algn="ctr">
+              <a:buNone/>
+            </a:pPr>
+            <a:r>
+              <a:rPr lang="en-US" sz="880" b="1" kern="0" spc="80" dirty="0">
                 <a:solidFill>
                   <a:srgbClr val="FFFFFF"/>
                 </a:solidFill>
@@ -7814,7 +7579,7 @@
           </a:bodyPr>
           <a:lstStyle/>
           <a:p>
-            <a:pPr algn="ctr" indent="0" marL="0">
+            <a:pPr marL="0" indent="0" algn="ctr">
               <a:buNone/>
             </a:pPr>
             <a:r>
@@ -7877,7 +7642,7 @@
           </a:bodyPr>
           <a:lstStyle/>
           <a:p>
-            <a:pPr algn="ctr" indent="0" marL="0">
+            <a:pPr marL="0" indent="0" algn="ctr">
               <a:buNone/>
             </a:pPr>
             <a:r>
@@ -7918,7 +7683,7 @@
           </a:bodyPr>
           <a:lstStyle/>
           <a:p>
-            <a:pPr indent="0" marL="0">
+            <a:pPr marL="0" indent="0">
               <a:buNone/>
             </a:pPr>
             <a:r>
@@ -7972,6 +7737,7 @@
         <a:solidFill>
           <a:srgbClr val="F4FBF8"/>
         </a:solidFill>
+        <a:effectLst/>
       </p:bgPr>
     </p:bg>
     <p:spTree>
@@ -8033,11 +7799,11 @@
           </a:bodyPr>
           <a:lstStyle/>
           <a:p>
-            <a:pPr indent="0" marL="0">
-              <a:buNone/>
-            </a:pPr>
-            <a:r>
-              <a:rPr lang="en-US" sz="820" b="1" spc="120" kern="0" dirty="0">
+            <a:pPr marL="0" indent="0">
+              <a:buNone/>
+            </a:pPr>
+            <a:r>
+              <a:rPr lang="en-US" sz="820" b="1" kern="0" spc="120" dirty="0">
                 <a:solidFill>
                   <a:srgbClr val="FFFFFF"/>
                 </a:solidFill>
@@ -8074,7 +7840,7 @@
           </a:bodyPr>
           <a:lstStyle/>
           <a:p>
-            <a:pPr indent="0" marL="0">
+            <a:pPr marL="0" indent="0">
               <a:buNone/>
             </a:pPr>
             <a:r>
@@ -8249,7 +8015,7 @@
           <a:bodyPr wrap="square" lIns="0" tIns="0" rIns="0" bIns="0" rtlCol="0" anchor="ctr"/>
           <a:lstStyle/>
           <a:p>
-            <a:pPr algn="ctr" indent="0" marL="0">
+            <a:pPr marL="0" indent="0" algn="ctr">
               <a:buNone/>
             </a:pPr>
             <a:r>
@@ -8357,7 +8123,7 @@
           <a:bodyPr wrap="square" lIns="0" tIns="0" rIns="0" bIns="0" rtlCol="0" anchor="ctr"/>
           <a:lstStyle/>
           <a:p>
-            <a:pPr algn="ctr" indent="0" marL="0">
+            <a:pPr marL="0" indent="0" algn="ctr">
               <a:buNone/>
             </a:pPr>
             <a:r>
@@ -8398,7 +8164,7 @@
           </a:bodyPr>
           <a:lstStyle/>
           <a:p>
-            <a:pPr indent="0" marL="0">
+            <a:pPr marL="0" indent="0">
               <a:buNone/>
             </a:pPr>
             <a:r>
@@ -8546,7 +8312,7 @@
           <a:bodyPr wrap="square" lIns="0" tIns="0" rIns="0" bIns="0" rtlCol="0" anchor="ctr"/>
           <a:lstStyle/>
           <a:p>
-            <a:pPr algn="ctr" indent="0" marL="0">
+            <a:pPr marL="0" indent="0" algn="ctr">
               <a:buNone/>
             </a:pPr>
             <a:r>
@@ -8587,7 +8353,7 @@
           </a:bodyPr>
           <a:lstStyle/>
           <a:p>
-            <a:pPr indent="0" marL="0">
+            <a:pPr marL="0" indent="0">
               <a:buNone/>
             </a:pPr>
             <a:r>
@@ -8706,7 +8472,7 @@
           </a:bodyPr>
           <a:lstStyle/>
           <a:p>
-            <a:pPr indent="0" marL="0">
+            <a:pPr marL="0" indent="0">
               <a:buNone/>
             </a:pPr>
             <a:r>
@@ -8760,6 +8526,7 @@
         <a:solidFill>
           <a:srgbClr val="123026"/>
         </a:solidFill>
+        <a:effectLst/>
       </p:bgPr>
     </p:bg>
     <p:spTree>
@@ -8837,11 +8604,11 @@
           <a:bodyPr wrap="square" lIns="0" tIns="0" rIns="0" bIns="0" rtlCol="0" anchor="ctr"/>
           <a:lstStyle/>
           <a:p>
-            <a:pPr indent="0" marL="0">
-              <a:buNone/>
-            </a:pPr>
-            <a:r>
-              <a:rPr lang="en-US" sz="1200" b="1" spc="350" kern="0" dirty="0">
+            <a:pPr marL="0" indent="0">
+              <a:buNone/>
+            </a:pPr>
+            <a:r>
+              <a:rPr lang="en-US" sz="1200" b="1" kern="0" spc="350" dirty="0">
                 <a:solidFill>
                   <a:srgbClr val="35C990"/>
                 </a:solidFill>
@@ -8878,7 +8645,7 @@
           </a:bodyPr>
           <a:lstStyle/>
           <a:p>
-            <a:pPr indent="0" marL="0">
+            <a:pPr marL="0" indent="0">
               <a:buNone/>
             </a:pPr>
             <a:r>
@@ -8895,7 +8662,7 @@
             <a:endParaRPr lang="en-US" sz="3500" dirty="0"/>
           </a:p>
           <a:p>
-            <a:pPr indent="0" marL="0">
+            <a:pPr marL="0" indent="0">
               <a:buNone/>
             </a:pPr>
             <a:r>
@@ -8936,7 +8703,7 @@
           </a:bodyPr>
           <a:lstStyle/>
           <a:p>
-            <a:pPr indent="0" marL="0">
+            <a:pPr marL="0" indent="0">
               <a:buNone/>
             </a:pPr>
             <a:r>
@@ -8953,7 +8720,7 @@
             <a:endParaRPr lang="en-US" sz="1540" dirty="0"/>
           </a:p>
           <a:p>
-            <a:pPr indent="0" marL="0">
+            <a:pPr marL="0" indent="0">
               <a:buNone/>
             </a:pPr>
             <a:r>
@@ -8970,7 +8737,7 @@
             <a:endParaRPr lang="en-US" sz="1540" dirty="0"/>
           </a:p>
           <a:p>
-            <a:pPr indent="0" marL="0">
+            <a:pPr marL="0" indent="0">
               <a:buNone/>
             </a:pPr>
             <a:r>
@@ -8987,7 +8754,7 @@
             <a:endParaRPr lang="en-US" sz="1540" dirty="0"/>
           </a:p>
           <a:p>
-            <a:pPr indent="0" marL="0">
+            <a:pPr marL="0" indent="0">
               <a:buNone/>
             </a:pPr>
             <a:r>
@@ -9070,7 +8837,7 @@
           <a:bodyPr wrap="square" lIns="0" tIns="0" rIns="0" bIns="0" rtlCol="0" anchor="ctr"/>
           <a:lstStyle/>
           <a:p>
-            <a:pPr algn="ctr" indent="0" marL="0">
+            <a:pPr marL="0" indent="0" algn="ctr">
               <a:buNone/>
             </a:pPr>
             <a:r>
@@ -9109,7 +8876,7 @@
           <a:bodyPr wrap="square" lIns="0" tIns="0" rIns="0" bIns="0" rtlCol="0" anchor="ctr"/>
           <a:lstStyle/>
           <a:p>
-            <a:pPr indent="0" marL="0">
+            <a:pPr marL="0" indent="0">
               <a:buNone/>
             </a:pPr>
             <a:r>
@@ -9168,7 +8935,7 @@
           <a:bodyPr wrap="square" lIns="0" tIns="0" rIns="0" bIns="0" rtlCol="0" anchor="ctr"/>
           <a:lstStyle/>
           <a:p>
-            <a:pPr algn="ctr" indent="0" marL="0">
+            <a:pPr marL="0" indent="0" algn="ctr">
               <a:buNone/>
             </a:pPr>
             <a:r>
@@ -9209,7 +8976,7 @@
           </a:bodyPr>
           <a:lstStyle/>
           <a:p>
-            <a:pPr indent="0" marL="0">
+            <a:pPr marL="0" indent="0">
               <a:buNone/>
             </a:pPr>
             <a:r>
@@ -9268,7 +9035,7 @@
           <a:bodyPr wrap="square" lIns="0" tIns="0" rIns="0" bIns="0" rtlCol="0" anchor="ctr"/>
           <a:lstStyle/>
           <a:p>
-            <a:pPr algn="ctr" indent="0" marL="0">
+            <a:pPr marL="0" indent="0" algn="ctr">
               <a:buNone/>
             </a:pPr>
             <a:r>
@@ -9309,7 +9076,7 @@
           </a:bodyPr>
           <a:lstStyle/>
           <a:p>
-            <a:pPr indent="0" marL="0">
+            <a:pPr marL="0" indent="0">
               <a:buNone/>
             </a:pPr>
             <a:r>
@@ -9326,7 +9093,7 @@
             <a:endParaRPr lang="en-US" sz="1480" dirty="0"/>
           </a:p>
           <a:p>
-            <a:pPr indent="0" marL="0">
+            <a:pPr marL="0" indent="0">
               <a:buNone/>
             </a:pPr>
             <a:r>
@@ -9385,7 +9152,7 @@
           <a:bodyPr wrap="square" lIns="0" tIns="0" rIns="0" bIns="0" rtlCol="0" anchor="ctr"/>
           <a:lstStyle/>
           <a:p>
-            <a:pPr algn="ctr" indent="0" marL="0">
+            <a:pPr marL="0" indent="0" algn="ctr">
               <a:buNone/>
             </a:pPr>
             <a:r>
@@ -9426,7 +9193,7 @@
           </a:bodyPr>
           <a:lstStyle/>
           <a:p>
-            <a:pPr indent="0" marL="0">
+            <a:pPr marL="0" indent="0">
               <a:buNone/>
             </a:pPr>
             <a:r>
@@ -9489,7 +9256,7 @@
           </a:bodyPr>
           <a:lstStyle/>
           <a:p>
-            <a:pPr indent="0" marL="0">
+            <a:pPr marL="0" indent="0">
               <a:buNone/>
             </a:pPr>
             <a:r>
@@ -9530,7 +9297,7 @@
           </a:bodyPr>
           <a:lstStyle/>
           <a:p>
-            <a:pPr indent="0" marL="0">
+            <a:pPr marL="0" indent="0">
               <a:buNone/>
             </a:pPr>
             <a:r>
@@ -9584,6 +9351,7 @@
         <a:solidFill>
           <a:srgbClr val="F4FBF8"/>
         </a:solidFill>
+        <a:effectLst/>
       </p:bgPr>
     </p:bg>
     <p:spTree>
@@ -9645,11 +9413,11 @@
           </a:bodyPr>
           <a:lstStyle/>
           <a:p>
-            <a:pPr indent="0" marL="0">
-              <a:buNone/>
-            </a:pPr>
-            <a:r>
-              <a:rPr lang="en-US" sz="820" b="1" spc="120" kern="0" dirty="0">
+            <a:pPr marL="0" indent="0">
+              <a:buNone/>
+            </a:pPr>
+            <a:r>
+              <a:rPr lang="en-US" sz="820" b="1" kern="0" spc="120" dirty="0">
                 <a:solidFill>
                   <a:srgbClr val="FFFFFF"/>
                 </a:solidFill>
@@ -9686,7 +9454,7 @@
           </a:bodyPr>
           <a:lstStyle/>
           <a:p>
-            <a:pPr indent="0" marL="0">
+            <a:pPr marL="0" indent="0">
               <a:buNone/>
             </a:pPr>
             <a:r>
@@ -9861,7 +9629,7 @@
           <a:bodyPr wrap="square" lIns="0" tIns="0" rIns="0" bIns="0" rtlCol="0" anchor="ctr"/>
           <a:lstStyle/>
           <a:p>
-            <a:pPr algn="ctr" indent="0" marL="0">
+            <a:pPr marL="0" indent="0" algn="ctr">
               <a:buNone/>
             </a:pPr>
             <a:r>
@@ -9942,7 +9710,7 @@
           <a:bodyPr wrap="square" lIns="0" tIns="0" rIns="0" bIns="0" rtlCol="0" anchor="ctr"/>
           <a:lstStyle/>
           <a:p>
-            <a:pPr indent="0" marL="0">
+            <a:pPr marL="0" indent="0">
               <a:buNone/>
             </a:pPr>
             <a:r>
@@ -9959,7 +9727,7 @@
             <a:endParaRPr lang="en-US" sz="2900" dirty="0"/>
           </a:p>
           <a:p>
-            <a:pPr indent="0" marL="0">
+            <a:pPr marL="0" indent="0">
               <a:buNone/>
             </a:pPr>
             <a:r>
@@ -9976,7 +9744,7 @@
             <a:endParaRPr lang="en-US" sz="2900" dirty="0"/>
           </a:p>
           <a:p>
-            <a:pPr indent="0" marL="0">
+            <a:pPr marL="0" indent="0">
               <a:buNone/>
             </a:pPr>
             <a:r>
@@ -10178,7 +9946,7 @@
           <a:bodyPr wrap="square" lIns="0" tIns="0" rIns="0" bIns="0" rtlCol="0" anchor="ctr"/>
           <a:lstStyle/>
           <a:p>
-            <a:pPr algn="ctr" indent="0" marL="0">
+            <a:pPr marL="0" indent="0" algn="ctr">
               <a:buNone/>
             </a:pPr>
             <a:r>
@@ -10219,7 +9987,7 @@
           </a:bodyPr>
           <a:lstStyle/>
           <a:p>
-            <a:pPr indent="0" marL="0">
+            <a:pPr marL="0" indent="0">
               <a:buNone/>
             </a:pPr>
             <a:r>
@@ -10305,7 +10073,7 @@
           <a:bodyPr wrap="square" lIns="0" tIns="0" rIns="0" bIns="0" rtlCol="0" anchor="ctr"/>
           <a:lstStyle/>
           <a:p>
-            <a:pPr algn="ctr" indent="0" marL="0">
+            <a:pPr marL="0" indent="0" algn="ctr">
               <a:buNone/>
             </a:pPr>
             <a:r>
@@ -10346,7 +10114,7 @@
           </a:bodyPr>
           <a:lstStyle/>
           <a:p>
-            <a:pPr indent="0" marL="0">
+            <a:pPr marL="0" indent="0">
               <a:buNone/>
             </a:pPr>
             <a:r>
@@ -10358,7 +10126,7 @@
                 <a:ea typeface="Aptos" pitchFamily="34" charset="-122"/>
                 <a:cs typeface="Aptos" pitchFamily="34" charset="-120"/>
               </a:rPr>
-              <a:t>Least privilege combines role, scope, and data rules. Invocation-only callers usually need Foundry Agent Consumer—not a developer role.</a:t>
+              <a:t>Least privilege combines role, resource scope, and data-level permissions. Invocation-only callers usually need Foundry Agent Consumer—not a developer role.</a:t>
             </a:r>
             <a:endParaRPr lang="en-US" sz="1530" dirty="0"/>
           </a:p>
@@ -10432,7 +10200,7 @@
           <a:bodyPr wrap="square" lIns="0" tIns="0" rIns="0" bIns="0" rtlCol="0" anchor="ctr"/>
           <a:lstStyle/>
           <a:p>
-            <a:pPr algn="ctr" indent="0" marL="0">
+            <a:pPr marL="0" indent="0" algn="ctr">
               <a:buNone/>
             </a:pPr>
             <a:r>
@@ -10473,7 +10241,7 @@
           </a:bodyPr>
           <a:lstStyle/>
           <a:p>
-            <a:pPr indent="0" marL="0">
+            <a:pPr marL="0" indent="0">
               <a:buNone/>
             </a:pPr>
             <a:r>
@@ -10559,7 +10327,7 @@
           <a:bodyPr wrap="square" lIns="0" tIns="0" rIns="0" bIns="0" rtlCol="0" anchor="ctr"/>
           <a:lstStyle/>
           <a:p>
-            <a:pPr algn="ctr" indent="0" marL="0">
+            <a:pPr marL="0" indent="0" algn="ctr">
               <a:buNone/>
             </a:pPr>
             <a:r>
@@ -10600,7 +10368,7 @@
           </a:bodyPr>
           <a:lstStyle/>
           <a:p>
-            <a:pPr indent="0" marL="0">
+            <a:pPr marL="0" indent="0">
               <a:buNone/>
             </a:pPr>
             <a:r>
@@ -10641,7 +10409,7 @@
           </a:bodyPr>
           <a:lstStyle/>
           <a:p>
-            <a:pPr indent="0" marL="0">
+            <a:pPr marL="0" indent="0">
               <a:buNone/>
             </a:pPr>
             <a:r>
@@ -10980,4 +10748,319 @@
     </a:ext>
   </a:extLst>
 </a:theme>
+</file>
+
+<file path=ppt/theme/theme2.xml><?xml version="1.0" encoding="utf-8"?>
+<a:theme xmlns:a="http://schemas.openxmlformats.org/drawingml/2006/main" name="Office Theme">
+  <a:themeElements>
+    <a:clrScheme name="Office">
+      <a:dk1>
+        <a:sysClr val="windowText" lastClr="000000"/>
+      </a:dk1>
+      <a:lt1>
+        <a:sysClr val="window" lastClr="FFFFFF"/>
+      </a:lt1>
+      <a:dk2>
+        <a:srgbClr val="0E2841"/>
+      </a:dk2>
+      <a:lt2>
+        <a:srgbClr val="E8E8E8"/>
+      </a:lt2>
+      <a:accent1>
+        <a:srgbClr val="156082"/>
+      </a:accent1>
+      <a:accent2>
+        <a:srgbClr val="E97132"/>
+      </a:accent2>
+      <a:accent3>
+        <a:srgbClr val="196B24"/>
+      </a:accent3>
+      <a:accent4>
+        <a:srgbClr val="0F9ED5"/>
+      </a:accent4>
+      <a:accent5>
+        <a:srgbClr val="A02B93"/>
+      </a:accent5>
+      <a:accent6>
+        <a:srgbClr val="4EA72E"/>
+      </a:accent6>
+      <a:hlink>
+        <a:srgbClr val="467886"/>
+      </a:hlink>
+      <a:folHlink>
+        <a:srgbClr val="96607D"/>
+      </a:folHlink>
+    </a:clrScheme>
+    <a:fontScheme name="Office">
+      <a:majorFont>
+        <a:latin typeface="Aptos Display" panose="02110004020202020204"/>
+        <a:ea typeface=""/>
+        <a:cs typeface=""/>
+        <a:font script="Jpan" typeface="游ゴシック Light"/>
+        <a:font script="Hang" typeface="맑은 고딕"/>
+        <a:font script="Hans" typeface="等线 Light"/>
+        <a:font script="Hant" typeface="新細明體"/>
+        <a:font script="Arab" typeface="Times New Roman"/>
+        <a:font script="Hebr" typeface="Times New Roman"/>
+        <a:font script="Thai" typeface="Angsana New"/>
+        <a:font script="Ethi" typeface="Nyala"/>
+        <a:font script="Beng" typeface="Vrinda"/>
+        <a:font script="Gujr" typeface="Shruti"/>
+        <a:font script="Khmr" typeface="MoolBoran"/>
+        <a:font script="Knda" typeface="Tunga"/>
+        <a:font script="Guru" typeface="Raavi"/>
+        <a:font script="Cans" typeface="Euphemia"/>
+        <a:font script="Cher" typeface="Plantagenet Cherokee"/>
+        <a:font script="Yiii" typeface="Microsoft Yi Baiti"/>
+        <a:font script="Tibt" typeface="Microsoft Himalaya"/>
+        <a:font script="Thaa" typeface="MV Boli"/>
+        <a:font script="Deva" typeface="Mangal"/>
+        <a:font script="Telu" typeface="Gautami"/>
+        <a:font script="Taml" typeface="Latha"/>
+        <a:font script="Syrc" typeface="Estrangelo Edessa"/>
+        <a:font script="Orya" typeface="Kalinga"/>
+        <a:font script="Mlym" typeface="Kartika"/>
+        <a:font script="Laoo" typeface="DokChampa"/>
+        <a:font script="Sinh" typeface="Iskoola Pota"/>
+        <a:font script="Mong" typeface="Mongolian Baiti"/>
+        <a:font script="Viet" typeface="Times New Roman"/>
+        <a:font script="Uigh" typeface="Microsoft Uighur"/>
+        <a:font script="Geor" typeface="Sylfaen"/>
+        <a:font script="Armn" typeface="Arial"/>
+        <a:font script="Bugi" typeface="Leelawadee UI"/>
+        <a:font script="Bopo" typeface="Microsoft JhengHei"/>
+        <a:font script="Java" typeface="Javanese Text"/>
+        <a:font script="Lisu" typeface="Segoe UI"/>
+        <a:font script="Mymr" typeface="Myanmar Text"/>
+        <a:font script="Nkoo" typeface="Ebrima"/>
+        <a:font script="Olck" typeface="Nirmala UI"/>
+        <a:font script="Osma" typeface="Ebrima"/>
+        <a:font script="Phag" typeface="Phagspa"/>
+        <a:font script="Syrn" typeface="Estrangelo Edessa"/>
+        <a:font script="Syrj" typeface="Estrangelo Edessa"/>
+        <a:font script="Syre" typeface="Estrangelo Edessa"/>
+        <a:font script="Sora" typeface="Nirmala UI"/>
+        <a:font script="Tale" typeface="Microsoft Tai Le"/>
+        <a:font script="Talu" typeface="Microsoft New Tai Lue"/>
+        <a:font script="Tfng" typeface="Ebrima"/>
+      </a:majorFont>
+      <a:minorFont>
+        <a:latin typeface="Aptos" panose="02110004020202020204"/>
+        <a:ea typeface=""/>
+        <a:cs typeface=""/>
+        <a:font script="Jpan" typeface="游ゴシック"/>
+        <a:font script="Hang" typeface="맑은 고딕"/>
+        <a:font script="Hans" typeface="等线"/>
+        <a:font script="Hant" typeface="新細明體"/>
+        <a:font script="Arab" typeface="Arial"/>
+        <a:font script="Hebr" typeface="Arial"/>
+        <a:font script="Thai" typeface="Cordia New"/>
+        <a:font script="Ethi" typeface="Nyala"/>
+        <a:font script="Beng" typeface="Vrinda"/>
+        <a:font script="Gujr" typeface="Shruti"/>
+        <a:font script="Khmr" typeface="DaunPenh"/>
+        <a:font script="Knda" typeface="Tunga"/>
+        <a:font script="Guru" typeface="Raavi"/>
+        <a:font script="Cans" typeface="Euphemia"/>
+        <a:font script="Cher" typeface="Plantagenet Cherokee"/>
+        <a:font script="Yiii" typeface="Microsoft Yi Baiti"/>
+        <a:font script="Tibt" typeface="Microsoft Himalaya"/>
+        <a:font script="Thaa" typeface="MV Boli"/>
+        <a:font script="Deva" typeface="Mangal"/>
+        <a:font script="Telu" typeface="Gautami"/>
+        <a:font script="Taml" typeface="Latha"/>
+        <a:font script="Syrc" typeface="Estrangelo Edessa"/>
+        <a:font script="Orya" typeface="Kalinga"/>
+        <a:font script="Mlym" typeface="Kartika"/>
+        <a:font script="Laoo" typeface="DokChampa"/>
+        <a:font script="Sinh" typeface="Iskoola Pota"/>
+        <a:font script="Mong" typeface="Mongolian Baiti"/>
+        <a:font script="Viet" typeface="Arial"/>
+        <a:font script="Uigh" typeface="Microsoft Uighur"/>
+        <a:font script="Geor" typeface="Sylfaen"/>
+        <a:font script="Armn" typeface="Arial"/>
+        <a:font script="Bugi" typeface="Leelawadee UI"/>
+        <a:font script="Bopo" typeface="Microsoft JhengHei"/>
+        <a:font script="Java" typeface="Javanese Text"/>
+        <a:font script="Lisu" typeface="Segoe UI"/>
+        <a:font script="Mymr" typeface="Myanmar Text"/>
+        <a:font script="Nkoo" typeface="Ebrima"/>
+        <a:font script="Olck" typeface="Nirmala UI"/>
+        <a:font script="Osma" typeface="Ebrima"/>
+        <a:font script="Phag" typeface="Phagspa"/>
+        <a:font script="Syrn" typeface="Estrangelo Edessa"/>
+        <a:font script="Syrj" typeface="Estrangelo Edessa"/>
+        <a:font script="Syre" typeface="Estrangelo Edessa"/>
+        <a:font script="Sora" typeface="Nirmala UI"/>
+        <a:font script="Tale" typeface="Microsoft Tai Le"/>
+        <a:font script="Talu" typeface="Microsoft New Tai Lue"/>
+        <a:font script="Tfng" typeface="Ebrima"/>
+      </a:minorFont>
+    </a:fontScheme>
+    <a:fmtScheme name="Office">
+      <a:fillStyleLst>
+        <a:solidFill>
+          <a:schemeClr val="phClr"/>
+        </a:solidFill>
+        <a:gradFill rotWithShape="1">
+          <a:gsLst>
+            <a:gs pos="0">
+              <a:schemeClr val="phClr">
+                <a:lumMod val="110000"/>
+                <a:satMod val="105000"/>
+                <a:tint val="67000"/>
+              </a:schemeClr>
+            </a:gs>
+            <a:gs pos="50000">
+              <a:schemeClr val="phClr">
+                <a:lumMod val="105000"/>
+                <a:satMod val="103000"/>
+                <a:tint val="73000"/>
+              </a:schemeClr>
+            </a:gs>
+            <a:gs pos="100000">
+              <a:schemeClr val="phClr">
+                <a:lumMod val="105000"/>
+                <a:satMod val="109000"/>
+                <a:tint val="81000"/>
+              </a:schemeClr>
+            </a:gs>
+          </a:gsLst>
+          <a:lin ang="5400000" scaled="0"/>
+        </a:gradFill>
+        <a:gradFill rotWithShape="1">
+          <a:gsLst>
+            <a:gs pos="0">
+              <a:schemeClr val="phClr">
+                <a:satMod val="103000"/>
+                <a:lumMod val="102000"/>
+                <a:tint val="94000"/>
+              </a:schemeClr>
+            </a:gs>
+            <a:gs pos="50000">
+              <a:schemeClr val="phClr">
+                <a:satMod val="110000"/>
+                <a:lumMod val="100000"/>
+                <a:shade val="100000"/>
+              </a:schemeClr>
+            </a:gs>
+            <a:gs pos="100000">
+              <a:schemeClr val="phClr">
+                <a:lumMod val="99000"/>
+                <a:satMod val="120000"/>
+                <a:shade val="78000"/>
+              </a:schemeClr>
+            </a:gs>
+          </a:gsLst>
+          <a:lin ang="5400000" scaled="0"/>
+        </a:gradFill>
+      </a:fillStyleLst>
+      <a:lnStyleLst>
+        <a:ln w="12700" cap="flat" cmpd="sng" algn="ctr">
+          <a:solidFill>
+            <a:schemeClr val="phClr"/>
+          </a:solidFill>
+          <a:prstDash val="solid"/>
+          <a:miter lim="800000"/>
+        </a:ln>
+        <a:ln w="19050" cap="flat" cmpd="sng" algn="ctr">
+          <a:solidFill>
+            <a:schemeClr val="phClr"/>
+          </a:solidFill>
+          <a:prstDash val="solid"/>
+          <a:miter lim="800000"/>
+        </a:ln>
+        <a:ln w="25400" cap="flat" cmpd="sng" algn="ctr">
+          <a:solidFill>
+            <a:schemeClr val="phClr"/>
+          </a:solidFill>
+          <a:prstDash val="solid"/>
+          <a:miter lim="800000"/>
+        </a:ln>
+      </a:lnStyleLst>
+      <a:effectStyleLst>
+        <a:effectStyle>
+          <a:effectLst/>
+        </a:effectStyle>
+        <a:effectStyle>
+          <a:effectLst/>
+        </a:effectStyle>
+        <a:effectStyle>
+          <a:effectLst>
+            <a:outerShdw blurRad="57150" dist="19050" dir="5400000" algn="ctr" rotWithShape="0">
+              <a:srgbClr val="000000">
+                <a:alpha val="63000"/>
+              </a:srgbClr>
+            </a:outerShdw>
+          </a:effectLst>
+        </a:effectStyle>
+      </a:effectStyleLst>
+      <a:bgFillStyleLst>
+        <a:solidFill>
+          <a:schemeClr val="phClr"/>
+        </a:solidFill>
+        <a:solidFill>
+          <a:schemeClr val="phClr">
+            <a:tint val="95000"/>
+            <a:satMod val="170000"/>
+          </a:schemeClr>
+        </a:solidFill>
+        <a:gradFill rotWithShape="1">
+          <a:gsLst>
+            <a:gs pos="0">
+              <a:schemeClr val="phClr">
+                <a:tint val="93000"/>
+                <a:satMod val="150000"/>
+                <a:shade val="98000"/>
+                <a:lumMod val="102000"/>
+              </a:schemeClr>
+            </a:gs>
+            <a:gs pos="50000">
+              <a:schemeClr val="phClr">
+                <a:tint val="98000"/>
+                <a:satMod val="130000"/>
+                <a:shade val="90000"/>
+                <a:lumMod val="103000"/>
+              </a:schemeClr>
+            </a:gs>
+            <a:gs pos="100000">
+              <a:schemeClr val="phClr">
+                <a:shade val="63000"/>
+                <a:satMod val="120000"/>
+              </a:schemeClr>
+            </a:gs>
+          </a:gsLst>
+          <a:lin ang="5400000" scaled="0"/>
+        </a:gradFill>
+      </a:bgFillStyleLst>
+    </a:fmtScheme>
+  </a:themeElements>
+  <a:objectDefaults>
+    <a:lnDef>
+      <a:spPr/>
+      <a:bodyPr/>
+      <a:lstStyle/>
+      <a:style>
+        <a:lnRef idx="2">
+          <a:schemeClr val="accent1"/>
+        </a:lnRef>
+        <a:fillRef idx="0">
+          <a:schemeClr val="accent1"/>
+        </a:fillRef>
+        <a:effectRef idx="1">
+          <a:schemeClr val="accent1"/>
+        </a:effectRef>
+        <a:fontRef idx="minor">
+          <a:schemeClr val="tx1"/>
+        </a:fontRef>
+      </a:style>
+    </a:lnDef>
+  </a:objectDefaults>
+  <a:extraClrSchemeLst/>
+  <a:extLst>
+    <a:ext uri="{05A4C25C-085E-4340-85A3-A5531E510DB2}">
+      <thm15:themeFamily xmlns:thm15="http://schemas.microsoft.com/office/thememl/2012/main" name="Office Theme" id="{2E142A2C-CD16-42D6-873A-C26D2A0506FA}" vid="{1BDDFF52-6CD6-40A5-AB3C-68EB2F1E4D0A}"/>
+    </a:ext>
+  </a:extLst>
+</a:theme>
 </file>
</xml_diff>